<commit_message>
Fix rotation of PDF
Signed-off-by: William So <polyipseity@gmail.com>
Private-commit: ae10a85d03e25560676dcb401b5b13033bb3aa18
</commit_message>
<xml_diff>
--- a/special/academia/HKUST/TEMG 3950/assignment W11/W10 Root Cause Analysis (Starbucks).pptx
+++ b/special/academia/HKUST/TEMG 3950/assignment W11/W10 Root Cause Analysis (Starbucks).pptx
@@ -265,7 +265,7 @@
           <a:p>
             <a:fld id="{2C7C8946-FA19-4747-8649-F6BD4CD27D46}" type="datetimeFigureOut">
               <a:rPr lang="zh-HK" altLang="en-US" smtClean="0"/>
-              <a:t>14/4/2024</a:t>
+              <a:t>24/6/2024</a:t>
             </a:fld>
             <a:endParaRPr lang="zh-HK" altLang="en-US"/>
           </a:p>
@@ -465,7 +465,7 @@
           <a:p>
             <a:fld id="{2C7C8946-FA19-4747-8649-F6BD4CD27D46}" type="datetimeFigureOut">
               <a:rPr lang="zh-HK" altLang="en-US" smtClean="0"/>
-              <a:t>14/4/2024</a:t>
+              <a:t>24/6/2024</a:t>
             </a:fld>
             <a:endParaRPr lang="zh-HK" altLang="en-US"/>
           </a:p>
@@ -675,7 +675,7 @@
           <a:p>
             <a:fld id="{2C7C8946-FA19-4747-8649-F6BD4CD27D46}" type="datetimeFigureOut">
               <a:rPr lang="zh-HK" altLang="en-US" smtClean="0"/>
-              <a:t>14/4/2024</a:t>
+              <a:t>24/6/2024</a:t>
             </a:fld>
             <a:endParaRPr lang="zh-HK" altLang="en-US"/>
           </a:p>
@@ -875,7 +875,7 @@
           <a:p>
             <a:fld id="{2C7C8946-FA19-4747-8649-F6BD4CD27D46}" type="datetimeFigureOut">
               <a:rPr lang="zh-HK" altLang="en-US" smtClean="0"/>
-              <a:t>14/4/2024</a:t>
+              <a:t>24/6/2024</a:t>
             </a:fld>
             <a:endParaRPr lang="zh-HK" altLang="en-US"/>
           </a:p>
@@ -1151,7 +1151,7 @@
           <a:p>
             <a:fld id="{2C7C8946-FA19-4747-8649-F6BD4CD27D46}" type="datetimeFigureOut">
               <a:rPr lang="zh-HK" altLang="en-US" smtClean="0"/>
-              <a:t>14/4/2024</a:t>
+              <a:t>24/6/2024</a:t>
             </a:fld>
             <a:endParaRPr lang="zh-HK" altLang="en-US"/>
           </a:p>
@@ -1419,7 +1419,7 @@
           <a:p>
             <a:fld id="{2C7C8946-FA19-4747-8649-F6BD4CD27D46}" type="datetimeFigureOut">
               <a:rPr lang="zh-HK" altLang="en-US" smtClean="0"/>
-              <a:t>14/4/2024</a:t>
+              <a:t>24/6/2024</a:t>
             </a:fld>
             <a:endParaRPr lang="zh-HK" altLang="en-US"/>
           </a:p>
@@ -1834,7 +1834,7 @@
           <a:p>
             <a:fld id="{2C7C8946-FA19-4747-8649-F6BD4CD27D46}" type="datetimeFigureOut">
               <a:rPr lang="zh-HK" altLang="en-US" smtClean="0"/>
-              <a:t>14/4/2024</a:t>
+              <a:t>24/6/2024</a:t>
             </a:fld>
             <a:endParaRPr lang="zh-HK" altLang="en-US"/>
           </a:p>
@@ -1976,7 +1976,7 @@
           <a:p>
             <a:fld id="{2C7C8946-FA19-4747-8649-F6BD4CD27D46}" type="datetimeFigureOut">
               <a:rPr lang="zh-HK" altLang="en-US" smtClean="0"/>
-              <a:t>14/4/2024</a:t>
+              <a:t>24/6/2024</a:t>
             </a:fld>
             <a:endParaRPr lang="zh-HK" altLang="en-US"/>
           </a:p>
@@ -2089,7 +2089,7 @@
           <a:p>
             <a:fld id="{2C7C8946-FA19-4747-8649-F6BD4CD27D46}" type="datetimeFigureOut">
               <a:rPr lang="zh-HK" altLang="en-US" smtClean="0"/>
-              <a:t>14/4/2024</a:t>
+              <a:t>24/6/2024</a:t>
             </a:fld>
             <a:endParaRPr lang="zh-HK" altLang="en-US"/>
           </a:p>
@@ -2402,7 +2402,7 @@
           <a:p>
             <a:fld id="{2C7C8946-FA19-4747-8649-F6BD4CD27D46}" type="datetimeFigureOut">
               <a:rPr lang="zh-HK" altLang="en-US" smtClean="0"/>
-              <a:t>14/4/2024</a:t>
+              <a:t>24/6/2024</a:t>
             </a:fld>
             <a:endParaRPr lang="zh-HK" altLang="en-US"/>
           </a:p>
@@ -2691,7 +2691,7 @@
           <a:p>
             <a:fld id="{2C7C8946-FA19-4747-8649-F6BD4CD27D46}" type="datetimeFigureOut">
               <a:rPr lang="zh-HK" altLang="en-US" smtClean="0"/>
-              <a:t>14/4/2024</a:t>
+              <a:t>24/6/2024</a:t>
             </a:fld>
             <a:endParaRPr lang="zh-HK" altLang="en-US"/>
           </a:p>
@@ -2934,7 +2934,7 @@
           <a:p>
             <a:fld id="{2C7C8946-FA19-4747-8649-F6BD4CD27D46}" type="datetimeFigureOut">
               <a:rPr lang="zh-HK" altLang="en-US" smtClean="0"/>
-              <a:t>14/4/2024</a:t>
+              <a:t>24/6/2024</a:t>
             </a:fld>
             <a:endParaRPr lang="zh-HK" altLang="en-US"/>
           </a:p>
@@ -3402,8 +3402,8 @@
           <a:lstStyle/>
           <a:p>
             <a:r>
-              <a:rPr lang="en-US" altLang="zh-HK" dirty="0"/>
-              <a:t>So Chun Hin</a:t>
+              <a:rPr lang="en-US" altLang="zh-HK"/>
+              <a:t>William So</a:t>
             </a:r>
             <a:endParaRPr lang="zh-HK" altLang="en-US" dirty="0"/>
           </a:p>

</xml_diff>